<commit_message>
Fix slide 6 layout: improve readability with listed items and larger font
Co-Authored-By: Claude Sonnet 4.6 <noreply@anthropic.com>
Claude-Session: https://claude.ai/code/session_01MpdtojYCZ3w6SNSG7q79MD
</commit_message>
<xml_diff>
--- a/Tesla_Filled.pptx
+++ b/Tesla_Filled.pptx
@@ -17218,14 +17218,14 @@
         </p:nvSpPr>
         <p:spPr>
           <a:xfrm>
-            <a:off x="430000" y="2100000"/>
-            <a:ext cx="2713333" cy="520000"/>
+            <a:off x="450000" y="2080000"/>
+            <a:ext cx="3900000" cy="340000"/>
           </a:xfrm>
           <a:prstGeom prst="rect">
             <a:avLst/>
           </a:prstGeom>
           <a:solidFill>
-            <a:srgbClr val="1A1A1A"/>
+            <a:srgbClr val="E31937"/>
           </a:solidFill>
           <a:ln>
             <a:noFill/>
@@ -17249,41 +17249,22 @@
           <a:bodyPr rtlCol="0" anchor="ctr" wrap="square"/>
           <a:lstStyle/>
           <a:p>
-            <a:pPr algn="ctr">
+            <a:pPr algn="l">
               <a:spcBef>
                 <a:spcPts val="600"/>
               </a:spcBef>
               <a:spcAft>
-                <a:spcPts val="200"/>
+                <a:spcPts val="100"/>
               </a:spcAft>
             </a:pPr>
             <a:r>
-              <a:rPr sz="1000" b="0">
-                <a:solidFill>
-                  <a:srgbClr val="AAAAAA"/>
+              <a:rPr sz="1300" b="1">
+                <a:solidFill>
+                  <a:srgbClr val="FFFFFF"/>
                 </a:solidFill>
                 <a:latin typeface="맑은 고딕"/>
               </a:rPr>
-              <a:t>영업이익률</a:t>
-            </a:r>
-          </a:p>
-          <a:p>
-            <a:pPr algn="ctr">
-              <a:spcBef>
-                <a:spcPts val="0"/>
-              </a:spcBef>
-              <a:spcAft>
-                <a:spcPts val="0"/>
-              </a:spcAft>
-            </a:pPr>
-            <a:r>
-              <a:rPr sz="1600" b="1">
-                <a:solidFill>
-                  <a:srgbClr val="FFFFFF"/>
-                </a:solidFill>
-                <a:latin typeface="맑은 고딕"/>
-              </a:rPr>
-              <a:t>17.2%  →  7.6%  ↓</a:t>
+              <a:t>📊  재무 현황 (2023 Q3)</a:t>
             </a:r>
           </a:p>
         </p:txBody>
@@ -17296,14 +17277,14 @@
         </p:nvSpPr>
         <p:spPr>
           <a:xfrm>
-            <a:off x="3223333" y="2100000"/>
-            <a:ext cx="2713333" cy="520000"/>
+            <a:off x="450000" y="2440000"/>
+            <a:ext cx="3900000" cy="700000"/>
           </a:xfrm>
           <a:prstGeom prst="rect">
             <a:avLst/>
           </a:prstGeom>
           <a:solidFill>
-            <a:srgbClr val="1A1A1A"/>
+            <a:srgbClr val="F0F0F0"/>
           </a:solidFill>
           <a:ln>
             <a:noFill/>
@@ -17327,41 +17308,60 @@
           <a:bodyPr rtlCol="0" anchor="ctr" wrap="square"/>
           <a:lstStyle/>
           <a:p>
-            <a:pPr algn="ctr">
+            <a:pPr algn="l">
               <a:spcBef>
-                <a:spcPts val="600"/>
+                <a:spcPts val="1000"/>
               </a:spcBef>
               <a:spcAft>
-                <a:spcPts val="200"/>
+                <a:spcPts val="100"/>
               </a:spcAft>
             </a:pPr>
             <a:r>
-              <a:rPr sz="1000" b="0">
-                <a:solidFill>
-                  <a:srgbClr val="AAAAAA"/>
+              <a:rPr sz="1200" b="1">
+                <a:solidFill>
+                  <a:srgbClr val="E31937"/>
                 </a:solidFill>
                 <a:latin typeface="맑은 고딕"/>
               </a:rPr>
-              <a:t>순이익 증감</a:t>
-            </a:r>
-          </a:p>
-          <a:p>
-            <a:pPr algn="ctr">
+              <a:t>영업이익률   17.2%  →  7.6%  ↓</a:t>
+            </a:r>
+          </a:p>
+          <a:p>
+            <a:pPr algn="l">
               <a:spcBef>
-                <a:spcPts val="0"/>
+                <a:spcPts val="200"/>
               </a:spcBef>
               <a:spcAft>
-                <a:spcPts val="0"/>
+                <a:spcPts val="100"/>
               </a:spcAft>
             </a:pPr>
             <a:r>
-              <a:rPr sz="1600" b="1">
-                <a:solidFill>
-                  <a:srgbClr val="FFFFFF"/>
+              <a:rPr sz="1200" b="1">
+                <a:solidFill>
+                  <a:srgbClr val="E31937"/>
                 </a:solidFill>
                 <a:latin typeface="맑은 고딕"/>
               </a:rPr>
-              <a:t>YoY  −44%</a:t>
+              <a:t>순이익 증감  YoY −44%</a:t>
+            </a:r>
+          </a:p>
+          <a:p>
+            <a:pPr algn="l">
+              <a:spcBef>
+                <a:spcPts val="200"/>
+              </a:spcBef>
+              <a:spcAft>
+                <a:spcPts val="100"/>
+              </a:spcAft>
+            </a:pPr>
+            <a:r>
+              <a:rPr sz="1200" b="1">
+                <a:solidFill>
+                  <a:srgbClr val="E31937"/>
+                </a:solidFill>
+                <a:latin typeface="맑은 고딕"/>
+              </a:rPr>
+              <a:t>美 시장점유율  62%  →  50%  ↓</a:t>
             </a:r>
           </a:p>
         </p:txBody>
@@ -17374,14 +17374,14 @@
         </p:nvSpPr>
         <p:spPr>
           <a:xfrm>
-            <a:off x="6016666" y="2100000"/>
-            <a:ext cx="2713333" cy="520000"/>
+            <a:off x="450000" y="3200000"/>
+            <a:ext cx="3900000" cy="340000"/>
           </a:xfrm>
           <a:prstGeom prst="rect">
             <a:avLst/>
           </a:prstGeom>
           <a:solidFill>
-            <a:srgbClr val="1A1A1A"/>
+            <a:srgbClr val="2C3E50"/>
           </a:solidFill>
           <a:ln>
             <a:noFill/>
@@ -17405,41 +17405,22 @@
           <a:bodyPr rtlCol="0" anchor="ctr" wrap="square"/>
           <a:lstStyle/>
           <a:p>
-            <a:pPr algn="ctr">
+            <a:pPr algn="l">
               <a:spcBef>
                 <a:spcPts val="600"/>
               </a:spcBef>
               <a:spcAft>
-                <a:spcPts val="200"/>
+                <a:spcPts val="100"/>
               </a:spcAft>
             </a:pPr>
             <a:r>
-              <a:rPr sz="1000" b="0">
-                <a:solidFill>
-                  <a:srgbClr val="AAAAAA"/>
+              <a:rPr sz="1300" b="1">
+                <a:solidFill>
+                  <a:srgbClr val="FFFFFF"/>
                 </a:solidFill>
                 <a:latin typeface="맑은 고딕"/>
               </a:rPr>
-              <a:t>美 시장점유율</a:t>
-            </a:r>
-          </a:p>
-          <a:p>
-            <a:pPr algn="ctr">
-              <a:spcBef>
-                <a:spcPts val="0"/>
-              </a:spcBef>
-              <a:spcAft>
-                <a:spcPts val="0"/>
-              </a:spcAft>
-            </a:pPr>
-            <a:r>
-              <a:rPr sz="1600" b="1">
-                <a:solidFill>
-                  <a:srgbClr val="FFFFFF"/>
-                </a:solidFill>
-                <a:latin typeface="맑은 고딕"/>
-              </a:rPr>
-              <a:t>62%  →  50%  ↓</a:t>
+              <a:t>⚖️  두 가지 시나리오</a:t>
             </a:r>
           </a:p>
         </p:txBody>
@@ -17452,14 +17433,14 @@
         </p:nvSpPr>
         <p:spPr>
           <a:xfrm>
-            <a:off x="430000" y="2700000"/>
-            <a:ext cx="4110000" cy="900000"/>
+            <a:off x="450000" y="3600000"/>
+            <a:ext cx="3900000" cy="860000"/>
           </a:xfrm>
           <a:prstGeom prst="rect">
             <a:avLst/>
           </a:prstGeom>
           <a:solidFill>
-            <a:srgbClr val="279E60"/>
+            <a:srgbClr val="1E8B4C"/>
           </a:solidFill>
           <a:ln>
             <a:noFill/>
@@ -17488,7 +17469,7 @@
                 <a:spcPts val="800"/>
               </a:spcBef>
               <a:spcAft>
-                <a:spcPts val="400"/>
+                <a:spcPts val="100"/>
               </a:spcAft>
             </a:pPr>
             <a:r>
@@ -17498,34 +17479,64 @@
                 </a:solidFill>
                 <a:latin typeface="맑은 고딕"/>
               </a:rPr>
-              <a:t>✓ Scenario A  |  성공 경로</a:t>
+              <a:t>✓  Scenario A  |  성공 경로</a:t>
             </a:r>
           </a:p>
           <a:p>
             <a:pPr algn="l">
               <a:spcBef>
-                <a:spcPts val="400"/>
+                <a:spcPts val="200"/>
               </a:spcBef>
               <a:spcAft>
-                <a:spcPts val="0"/>
+                <a:spcPts val="100"/>
               </a:spcAft>
             </a:pPr>
             <a:r>
-              <a:rPr sz="900" b="0">
-                <a:solidFill>
-                  <a:srgbClr val="DDFFDD"/>
+              <a:rPr sz="1100" b="0">
+                <a:solidFill>
+                  <a:srgbClr val="CCFFCC"/>
                 </a:solidFill>
                 <a:latin typeface="맑은 고딕"/>
               </a:rPr>
-              <a:t>볼륨↑ → 배터리 원가↓ → FSD 구독 시장 확대</a:t>
-            </a:r>
-            <a:br/>
-            <a:r>
-              <a:t>→ 소프트웨어 고마진으로 차량 마진 하락 상쇄</a:t>
-            </a:r>
-            <a:br/>
-            <a:r>
-              <a:t>→ 에너지·보험·충전 번들 수익으로 지속 성장</a:t>
+              <a:t>볼륨↑  →  배터리 원가↓</a:t>
+            </a:r>
+          </a:p>
+          <a:p>
+            <a:pPr algn="l">
+              <a:spcBef>
+                <a:spcPts val="200"/>
+              </a:spcBef>
+              <a:spcAft>
+                <a:spcPts val="100"/>
+              </a:spcAft>
+            </a:pPr>
+            <a:r>
+              <a:rPr sz="1100" b="0">
+                <a:solidFill>
+                  <a:srgbClr val="CCFFCC"/>
+                </a:solidFill>
+                <a:latin typeface="맑은 고딕"/>
+              </a:rPr>
+              <a:t>FSD 구독 시장 확대  →  고마진 반복 수익 확보</a:t>
+            </a:r>
+          </a:p>
+          <a:p>
+            <a:pPr algn="l">
+              <a:spcBef>
+                <a:spcPts val="200"/>
+              </a:spcBef>
+              <a:spcAft>
+                <a:spcPts val="100"/>
+              </a:spcAft>
+            </a:pPr>
+            <a:r>
+              <a:rPr sz="1100" b="0">
+                <a:solidFill>
+                  <a:srgbClr val="CCFFCC"/>
+                </a:solidFill>
+                <a:latin typeface="맑은 고딕"/>
+              </a:rPr>
+              <a:t>소프트웨어·에너지 수익으로 차량 마진 하락 상쇄</a:t>
             </a:r>
           </a:p>
         </p:txBody>
@@ -17538,8 +17549,8 @@
         </p:nvSpPr>
         <p:spPr>
           <a:xfrm>
-            <a:off x="4620000" y="2700000"/>
-            <a:ext cx="4110000" cy="900000"/>
+            <a:off x="450000" y="4520000"/>
+            <a:ext cx="3900000" cy="860000"/>
           </a:xfrm>
           <a:prstGeom prst="rect">
             <a:avLst/>
@@ -17574,7 +17585,7 @@
                 <a:spcPts val="800"/>
               </a:spcBef>
               <a:spcAft>
-                <a:spcPts val="400"/>
+                <a:spcPts val="100"/>
               </a:spcAft>
             </a:pPr>
             <a:r>
@@ -17584,34 +17595,64 @@
                 </a:solidFill>
                 <a:latin typeface="맑은 고딕"/>
               </a:rPr>
-              <a:t>✗ Scenario B  |  위험 경로</a:t>
+              <a:t>✗  Scenario B  |  위험 경로</a:t>
             </a:r>
           </a:p>
           <a:p>
             <a:pPr algn="l">
               <a:spcBef>
-                <a:spcPts val="400"/>
+                <a:spcPts val="200"/>
               </a:spcBef>
               <a:spcAft>
-                <a:spcPts val="0"/>
+                <a:spcPts val="100"/>
               </a:spcAft>
             </a:pPr>
             <a:r>
-              <a:rPr sz="900" b="0">
+              <a:rPr sz="1100" b="0">
                 <a:solidFill>
                   <a:srgbClr val="FFDDDD"/>
                 </a:solidFill>
                 <a:latin typeface="맑은 고딕"/>
               </a:rPr>
-              <a:t>브랜드 희석 → 기존 고소득 고객 이탈</a:t>
-            </a:r>
-            <a:br/>
-            <a:r>
-              <a:t>→ ASP(평균판매가) 하락 → 마진 구조 붕괴</a:t>
-            </a:r>
-            <a:br/>
-            <a:r>
-              <a:t>→ BYD 마진 4~5% 구조 추종 시 수익성 모델 붕괴</a:t>
+              <a:t>브랜드 희석  →  기존 고소득 고객 이탈</a:t>
+            </a:r>
+          </a:p>
+          <a:p>
+            <a:pPr algn="l">
+              <a:spcBef>
+                <a:spcPts val="200"/>
+              </a:spcBef>
+              <a:spcAft>
+                <a:spcPts val="100"/>
+              </a:spcAft>
+            </a:pPr>
+            <a:r>
+              <a:rPr sz="1100" b="0">
+                <a:solidFill>
+                  <a:srgbClr val="FFDDDD"/>
+                </a:solidFill>
+                <a:latin typeface="맑은 고딕"/>
+              </a:rPr>
+              <a:t>ASP(평균판매가) 하락  →  마진 구조 붕괴</a:t>
+            </a:r>
+          </a:p>
+          <a:p>
+            <a:pPr algn="l">
+              <a:spcBef>
+                <a:spcPts val="200"/>
+              </a:spcBef>
+              <a:spcAft>
+                <a:spcPts val="100"/>
+              </a:spcAft>
+            </a:pPr>
+            <a:r>
+              <a:rPr sz="1100" b="0">
+                <a:solidFill>
+                  <a:srgbClr val="FFDDDD"/>
+                </a:solidFill>
+                <a:latin typeface="맑은 고딕"/>
+              </a:rPr>
+              <a:t>BYD식 마진 4~5% 구조 추종 시 수익성 모델 붕괴</a:t>
             </a:r>
           </a:p>
         </p:txBody>
@@ -17624,14 +17665,14 @@
         </p:nvSpPr>
         <p:spPr>
           <a:xfrm>
-            <a:off x="430000" y="3680000"/>
-            <a:ext cx="2713333" cy="1400000"/>
+            <a:off x="4430000" y="2080000"/>
+            <a:ext cx="4220000" cy="340000"/>
           </a:xfrm>
           <a:prstGeom prst="rect">
             <a:avLst/>
           </a:prstGeom>
           <a:solidFill>
-            <a:srgbClr val="164F96"/>
+            <a:srgbClr val="1A1A1A"/>
           </a:solidFill>
           <a:ln>
             <a:noFill/>
@@ -17657,51 +17698,20 @@
           <a:p>
             <a:pPr algn="l">
               <a:spcBef>
-                <a:spcPts val="800"/>
+                <a:spcPts val="600"/>
               </a:spcBef>
               <a:spcAft>
-                <a:spcPts val="400"/>
+                <a:spcPts val="100"/>
               </a:spcAft>
             </a:pPr>
             <a:r>
-              <a:rPr sz="1100" b="1">
+              <a:rPr sz="1300" b="1">
                 <a:solidFill>
                   <a:srgbClr val="FFFFFF"/>
                 </a:solidFill>
                 <a:latin typeface="맑은 고딕"/>
               </a:rPr>
-              <a:t>🔬 해자 ① 기술 우위</a:t>
-            </a:r>
-          </a:p>
-          <a:p>
-            <a:pPr algn="l">
-              <a:spcBef>
-                <a:spcPts val="400"/>
-              </a:spcBef>
-              <a:spcAft>
-                <a:spcPts val="0"/>
-              </a:spcAft>
-            </a:pPr>
-            <a:r>
-              <a:rPr sz="900" b="0">
-                <a:solidFill>
-                  <a:srgbClr val="DDDDEE"/>
-                </a:solidFill>
-                <a:latin typeface="맑은 고딕"/>
-              </a:rPr>
-              <a:t>FSD 완성도 조기 확보</a:t>
-            </a:r>
-            <a:br/>
-            <a:r>
-              <a:t>4680 배터리 양산 가속</a:t>
-            </a:r>
-            <a:br/>
-            <a:r>
-              <a:t>수백만 대 주행 데이터 독점</a:t>
-            </a:r>
-            <a:br/>
-            <a:r>
-              <a:t>→ 경쟁사 단기 복제 불가</a:t>
+              <a:t>🏰  선두 유지 전략 : 3가지 해자(Moat)</a:t>
             </a:r>
           </a:p>
         </p:txBody>
@@ -17714,14 +17724,14 @@
         </p:nvSpPr>
         <p:spPr>
           <a:xfrm>
-            <a:off x="3223333" y="3680000"/>
-            <a:ext cx="2713333" cy="1400000"/>
+            <a:off x="4430000" y="2440000"/>
+            <a:ext cx="4220000" cy="960000"/>
           </a:xfrm>
           <a:prstGeom prst="rect">
             <a:avLst/>
           </a:prstGeom>
           <a:solidFill>
-            <a:srgbClr val="2C3E50"/>
+            <a:srgbClr val="164F96"/>
           </a:solidFill>
           <a:ln>
             <a:noFill/>
@@ -17750,48 +17760,74 @@
                 <a:spcPts val="800"/>
               </a:spcBef>
               <a:spcAft>
-                <a:spcPts val="400"/>
+                <a:spcPts val="100"/>
               </a:spcAft>
             </a:pPr>
             <a:r>
-              <a:rPr sz="1100" b="1">
+              <a:rPr sz="1200" b="1">
                 <a:solidFill>
                   <a:srgbClr val="FFFFFF"/>
                 </a:solidFill>
                 <a:latin typeface="맑은 고딕"/>
               </a:rPr>
-              <a:t>⚡ 해자 ② 생태계 우위</a:t>
+              <a:t>🔬  해자 ①  기술 우위</a:t>
             </a:r>
           </a:p>
           <a:p>
             <a:pPr algn="l">
               <a:spcBef>
-                <a:spcPts val="400"/>
+                <a:spcPts val="200"/>
               </a:spcBef>
               <a:spcAft>
-                <a:spcPts val="0"/>
+                <a:spcPts val="100"/>
               </a:spcAft>
             </a:pPr>
             <a:r>
-              <a:rPr sz="900" b="0">
-                <a:solidFill>
-                  <a:srgbClr val="DDDDEE"/>
+              <a:rPr sz="1100" b="0">
+                <a:solidFill>
+                  <a:srgbClr val="CCDDFF"/>
                 </a:solidFill>
                 <a:latin typeface="맑은 고딕"/>
               </a:rPr>
-              <a:t>Supercharger → 수익 인프라 전환</a:t>
-            </a:r>
-            <a:br/>
-            <a:r>
-              <a:t>에너지·차량·보험 번들 락인(Lock-in)</a:t>
-            </a:r>
-            <a:br/>
-            <a:r>
-              <a:t>V2G 상용화 → 이탈 비용 급상승</a:t>
-            </a:r>
-            <a:br/>
-            <a:r>
-              <a:t>→ Tesla 생태계 안이 더 유리</a:t>
+              <a:t>FSD 완성도 조기 확보</a:t>
+            </a:r>
+          </a:p>
+          <a:p>
+            <a:pPr algn="l">
+              <a:spcBef>
+                <a:spcPts val="200"/>
+              </a:spcBef>
+              <a:spcAft>
+                <a:spcPts val="100"/>
+              </a:spcAft>
+            </a:pPr>
+            <a:r>
+              <a:rPr sz="1100" b="0">
+                <a:solidFill>
+                  <a:srgbClr val="CCDDFF"/>
+                </a:solidFill>
+                <a:latin typeface="맑은 고딕"/>
+              </a:rPr>
+              <a:t>4680 배터리 양산 가속  →  원가 경쟁력 확보</a:t>
+            </a:r>
+          </a:p>
+          <a:p>
+            <a:pPr algn="l">
+              <a:spcBef>
+                <a:spcPts val="200"/>
+              </a:spcBef>
+              <a:spcAft>
+                <a:spcPts val="100"/>
+              </a:spcAft>
+            </a:pPr>
+            <a:r>
+              <a:rPr sz="1100" b="0">
+                <a:solidFill>
+                  <a:srgbClr val="CCDDFF"/>
+                </a:solidFill>
+                <a:latin typeface="맑은 고딕"/>
+              </a:rPr>
+              <a:t>수백만 대 주행 데이터 독점  →  경쟁사 복제 불가</a:t>
             </a:r>
           </a:p>
         </p:txBody>
@@ -17804,14 +17840,14 @@
         </p:nvSpPr>
         <p:spPr>
           <a:xfrm>
-            <a:off x="6016666" y="3680000"/>
-            <a:ext cx="2713333" cy="1400000"/>
+            <a:off x="4430000" y="3460000"/>
+            <a:ext cx="4220000" cy="960000"/>
           </a:xfrm>
           <a:prstGeom prst="rect">
             <a:avLst/>
           </a:prstGeom>
           <a:solidFill>
-            <a:srgbClr val="3D3D3D"/>
+            <a:srgbClr val="2C3E50"/>
           </a:solidFill>
           <a:ln>
             <a:noFill/>
@@ -17840,48 +17876,74 @@
                 <a:spcPts val="800"/>
               </a:spcBef>
               <a:spcAft>
-                <a:spcPts val="400"/>
+                <a:spcPts val="100"/>
               </a:spcAft>
             </a:pPr>
             <a:r>
-              <a:rPr sz="1100" b="1">
+              <a:rPr sz="1200" b="1">
                 <a:solidFill>
                   <a:srgbClr val="FFFFFF"/>
                 </a:solidFill>
                 <a:latin typeface="맑은 고딕"/>
               </a:rPr>
-              <a:t>🌍 해자 ③ 브랜드·미션</a:t>
+              <a:t>⚡  해자 ②  생태계 우위</a:t>
             </a:r>
           </a:p>
           <a:p>
             <a:pPr algn="l">
               <a:spcBef>
-                <a:spcPts val="400"/>
+                <a:spcPts val="200"/>
               </a:spcBef>
               <a:spcAft>
-                <a:spcPts val="0"/>
+                <a:spcPts val="100"/>
               </a:spcAft>
             </a:pPr>
             <a:r>
-              <a:rPr sz="900" b="0">
-                <a:solidFill>
-                  <a:srgbClr val="DDDDEE"/>
+              <a:rPr sz="1100" b="0">
+                <a:solidFill>
+                  <a:srgbClr val="CCEEFF"/>
                 </a:solidFill>
                 <a:latin typeface="맑은 고딕"/>
               </a:rPr>
-              <a:t>대중 시장엔 '경제적 합리성' 메시지</a:t>
-            </a:r>
-            <a:br/>
-            <a:r>
-              <a:t>형평성 내러티브 선점 (CSR이 아닌 전략)</a:t>
-            </a:r>
-            <a:br/>
-            <a:r>
-              <a:t>CEO 리스크 분산 — 브랜드 독립성 강화</a:t>
-            </a:r>
-            <a:br/>
-            <a:r>
-              <a:t>→ 미션 중심 장기 충성도</a:t>
+              <a:t>Supercharger  →  수익 인프라로 전환</a:t>
+            </a:r>
+          </a:p>
+          <a:p>
+            <a:pPr algn="l">
+              <a:spcBef>
+                <a:spcPts val="200"/>
+              </a:spcBef>
+              <a:spcAft>
+                <a:spcPts val="100"/>
+              </a:spcAft>
+            </a:pPr>
+            <a:r>
+              <a:rPr sz="1100" b="0">
+                <a:solidFill>
+                  <a:srgbClr val="CCEEFF"/>
+                </a:solidFill>
+                <a:latin typeface="맑은 고딕"/>
+              </a:rPr>
+              <a:t>에너지·차량·보험 번들  →  Lock-in 구조 강화</a:t>
+            </a:r>
+          </a:p>
+          <a:p>
+            <a:pPr algn="l">
+              <a:spcBef>
+                <a:spcPts val="200"/>
+              </a:spcBef>
+              <a:spcAft>
+                <a:spcPts val="100"/>
+              </a:spcAft>
+            </a:pPr>
+            <a:r>
+              <a:rPr sz="1100" b="0">
+                <a:solidFill>
+                  <a:srgbClr val="CCEEFF"/>
+                </a:solidFill>
+                <a:latin typeface="맑은 고딕"/>
+              </a:rPr>
+              <a:t>V2G 상용화  →  이탈 비용 급상승</a:t>
             </a:r>
           </a:p>
         </p:txBody>
@@ -17894,19 +17956,17 @@
         </p:nvSpPr>
         <p:spPr>
           <a:xfrm>
-            <a:off x="430000" y="5160000"/>
-            <a:ext cx="8220000" cy="300000"/>
+            <a:off x="4430000" y="4480000"/>
+            <a:ext cx="4220000" cy="960000"/>
           </a:xfrm>
           <a:prstGeom prst="rect">
             <a:avLst/>
           </a:prstGeom>
           <a:solidFill>
-            <a:srgbClr val="F9F2EC"/>
-          </a:solidFill>
-          <a:ln w="9525">
-            <a:solidFill>
-              <a:srgbClr val="E31937"/>
-            </a:solidFill>
+            <a:srgbClr val="555555"/>
+          </a:solidFill>
+          <a:ln>
+            <a:noFill/>
           </a:ln>
         </p:spPr>
         <p:style>
@@ -17927,22 +17987,138 @@
           <a:bodyPr rtlCol="0" anchor="ctr" wrap="square"/>
           <a:lstStyle/>
           <a:p>
+            <a:pPr algn="l">
+              <a:spcBef>
+                <a:spcPts val="800"/>
+              </a:spcBef>
+              <a:spcAft>
+                <a:spcPts val="100"/>
+              </a:spcAft>
+            </a:pPr>
+            <a:r>
+              <a:rPr sz="1200" b="1">
+                <a:solidFill>
+                  <a:srgbClr val="FFFFFF"/>
+                </a:solidFill>
+                <a:latin typeface="맑은 고딕"/>
+              </a:rPr>
+              <a:t>🌍  해자 ③  브랜드·미션 우위</a:t>
+            </a:r>
+          </a:p>
+          <a:p>
+            <a:pPr algn="l">
+              <a:spcBef>
+                <a:spcPts val="200"/>
+              </a:spcBef>
+              <a:spcAft>
+                <a:spcPts val="100"/>
+              </a:spcAft>
+            </a:pPr>
+            <a:r>
+              <a:rPr sz="1100" b="0">
+                <a:solidFill>
+                  <a:srgbClr val="EEEEEE"/>
+                </a:solidFill>
+                <a:latin typeface="맑은 고딕"/>
+              </a:rPr>
+              <a:t>대중 시장엔 '경제적 합리성' 메시지로 전환</a:t>
+            </a:r>
+          </a:p>
+          <a:p>
+            <a:pPr algn="l">
+              <a:spcBef>
+                <a:spcPts val="200"/>
+              </a:spcBef>
+              <a:spcAft>
+                <a:spcPts val="100"/>
+              </a:spcAft>
+            </a:pPr>
+            <a:r>
+              <a:rPr sz="1100" b="0">
+                <a:solidFill>
+                  <a:srgbClr val="EEEEEE"/>
+                </a:solidFill>
+                <a:latin typeface="맑은 고딕"/>
+              </a:rPr>
+              <a:t>형평성 내러티브 선점  (CSR이 아닌 핵심 전략)</a:t>
+            </a:r>
+          </a:p>
+          <a:p>
+            <a:pPr algn="l">
+              <a:spcBef>
+                <a:spcPts val="200"/>
+              </a:spcBef>
+              <a:spcAft>
+                <a:spcPts val="100"/>
+              </a:spcAft>
+            </a:pPr>
+            <a:r>
+              <a:rPr sz="1100" b="0">
+                <a:solidFill>
+                  <a:srgbClr val="EEEEEE"/>
+                </a:solidFill>
+                <a:latin typeface="맑은 고딕"/>
+              </a:rPr>
+              <a:t>CEO 리스크 분산  →  브랜드 독립성 강화</a:t>
+            </a:r>
+          </a:p>
+        </p:txBody>
+      </p:sp>
+      <p:sp>
+        <p:nvSpPr>
+          <p:cNvPr id="18" name="Rectangle 17"/>
+          <p:cNvSpPr/>
+          <p:nvPr/>
+        </p:nvSpPr>
+        <p:spPr>
+          <a:xfrm>
+            <a:off x="450000" y="5500000"/>
+            <a:ext cx="8200000" cy="340000"/>
+          </a:xfrm>
+          <a:prstGeom prst="rect">
+            <a:avLst/>
+          </a:prstGeom>
+          <a:solidFill>
+            <a:srgbClr val="1A1A1A"/>
+          </a:solidFill>
+          <a:ln>
+            <a:noFill/>
+          </a:ln>
+        </p:spPr>
+        <p:style>
+          <a:lnRef idx="1">
+            <a:schemeClr val="accent1"/>
+          </a:lnRef>
+          <a:fillRef idx="3">
+            <a:schemeClr val="accent1"/>
+          </a:fillRef>
+          <a:effectRef idx="2">
+            <a:schemeClr val="accent1"/>
+          </a:effectRef>
+          <a:fontRef idx="minor">
+            <a:schemeClr val="lt1"/>
+          </a:fontRef>
+        </p:style>
+        <p:txBody>
+          <a:bodyPr rtlCol="0" anchor="ctr" wrap="square"/>
+          <a:lstStyle/>
+          <a:p>
             <a:pPr algn="ctr">
               <a:spcBef>
                 <a:spcPts val="800"/>
               </a:spcBef>
               <a:spcAft>
-                <a:spcPts val="0"/>
+                <a:spcPts val="100"/>
               </a:spcAft>
             </a:pPr>
             <a:r>
-              <a:rPr sz="1100" b="1">
-                <a:solidFill>
-                  <a:srgbClr val="E31937"/>
+              <a:rPr sz="1200" b="1">
+                <a:solidFill>
+                  <a:srgbClr val="FFCC00"/>
                 </a:solidFill>
                 <a:latin typeface="맑은 고딕"/>
               </a:rPr>
-              <a:t>결론  ·  "차를 팔고 끝나는 모델"  →  에너지·소프트웨어 구독 플랫폼 회사로의 전환이 장기 생존 전략</a:t>
+              <a:t>결론  ·  "차를 팔고 끝나는 모델"  →  에너지 · 소프트웨어 구독 플랫폼 회사로의 전환이 Tesla의 장기 생존 전략</a:t>
             </a:r>
           </a:p>
         </p:txBody>

</xml_diff>

<commit_message>
Redesign slides 4 and 5 with listed items and consistent style
Co-Authored-By: Claude Sonnet 4.6 <noreply@anthropic.com>
Claude-Session: https://claude.ai/code/session_01MpdtojYCZ3w6SNSG7q79MD
</commit_message>
<xml_diff>
--- a/Tesla_Filled.pptx
+++ b/Tesla_Filled.pptx
@@ -15307,8 +15307,8 @@
         </p:nvSpPr>
         <p:spPr>
           <a:xfrm>
-            <a:off x="450000" y="2100000"/>
-            <a:ext cx="4008560" cy="370000"/>
+            <a:off x="450000" y="2090000"/>
+            <a:ext cx="3850000" cy="340000"/>
           </a:xfrm>
           <a:prstGeom prst="rect">
             <a:avLst/>
@@ -15340,10 +15340,10 @@
           <a:p>
             <a:pPr algn="l">
               <a:spcBef>
-                <a:spcPts val="400"/>
+                <a:spcPts val="700"/>
               </a:spcBef>
               <a:spcAft>
-                <a:spcPts val="0"/>
+                <a:spcPts val="100"/>
               </a:spcAft>
             </a:pPr>
             <a:r>
@@ -15353,7 +15353,7 @@
                 </a:solidFill>
                 <a:latin typeface="맑은 고딕"/>
               </a:rPr>
-              <a:t>▸ 제품 전략 : 계단식 확장</a:t>
+              <a:t>▸  제품 전략 : 계단식 확장</a:t>
             </a:r>
           </a:p>
         </p:txBody>
@@ -15366,14 +15366,14 @@
         </p:nvSpPr>
         <p:spPr>
           <a:xfrm>
-            <a:off x="450000" y="2492860"/>
-            <a:ext cx="4008560" cy="560000"/>
+            <a:off x="450000" y="2450000"/>
+            <a:ext cx="3850000" cy="870000"/>
           </a:xfrm>
           <a:prstGeom prst="rect">
             <a:avLst/>
           </a:prstGeom>
           <a:solidFill>
-            <a:srgbClr val="E31937"/>
+            <a:srgbClr val="2C3E50"/>
           </a:solidFill>
           <a:ln>
             <a:noFill/>
@@ -15399,39 +15399,39 @@
           <a:p>
             <a:pPr algn="l">
               <a:spcBef>
-                <a:spcPts val="600"/>
+                <a:spcPts val="1000"/>
               </a:spcBef>
               <a:spcAft>
-                <a:spcPts val="0"/>
+                <a:spcPts val="100"/>
               </a:spcAft>
             </a:pPr>
             <a:r>
-              <a:rPr sz="1200" b="1">
-                <a:solidFill>
-                  <a:srgbClr val="FFFFFF"/>
+              <a:rPr sz="1300" b="1">
+                <a:solidFill>
+                  <a:srgbClr val="FFCC00"/>
                 </a:solidFill>
                 <a:latin typeface="맑은 고딕"/>
               </a:rPr>
-              <a:t>① Premium</a:t>
+              <a:t>①  Premium</a:t>
             </a:r>
           </a:p>
           <a:p>
             <a:pPr algn="l">
               <a:spcBef>
-                <a:spcPts val="200"/>
+                <a:spcPts val="400"/>
               </a:spcBef>
               <a:spcAft>
-                <a:spcPts val="0"/>
+                <a:spcPts val="100"/>
               </a:spcAft>
             </a:pPr>
             <a:r>
-              <a:rPr sz="1000" b="0">
-                <a:solidFill>
-                  <a:srgbClr val="FFCCCC"/>
+              <a:rPr sz="1100" b="0">
+                <a:solidFill>
+                  <a:srgbClr val="DDDDFF"/>
                 </a:solidFill>
                 <a:latin typeface="맑은 고딕"/>
               </a:rPr>
-              <a:t>Model S / X · Cybertruck</a:t>
+              <a:t>Model S / X  ·  Cybertruck</a:t>
             </a:r>
           </a:p>
           <a:p>
@@ -15440,17 +15440,36 @@
                 <a:spcPts val="300"/>
               </a:spcBef>
               <a:spcAft>
-                <a:spcPts val="0"/>
+                <a:spcPts val="100"/>
               </a:spcAft>
             </a:pPr>
             <a:r>
-              <a:rPr sz="900" b="0">
-                <a:solidFill>
-                  <a:srgbClr val="DDDDDD"/>
+              <a:rPr sz="1100" b="0">
+                <a:solidFill>
+                  <a:srgbClr val="DDDDFF"/>
                 </a:solidFill>
                 <a:latin typeface="맑은 고딕"/>
               </a:rPr>
-              <a:t>고소득 테크 얼리어답터 — 브랜드 핵심 수호</a:t>
+              <a:t>대상  :  고소득 테크 얼리어답터</a:t>
+            </a:r>
+          </a:p>
+          <a:p>
+            <a:pPr algn="l">
+              <a:spcBef>
+                <a:spcPts val="300"/>
+              </a:spcBef>
+              <a:spcAft>
+                <a:spcPts val="100"/>
+              </a:spcAft>
+            </a:pPr>
+            <a:r>
+              <a:rPr sz="1100" b="0">
+                <a:solidFill>
+                  <a:srgbClr val="DDDDFF"/>
+                </a:solidFill>
+                <a:latin typeface="맑은 고딕"/>
+              </a:rPr>
+              <a:t>전략  :  브랜드 핵심 수호 — 마진·이미지 최우선</a:t>
             </a:r>
           </a:p>
         </p:txBody>
@@ -15463,14 +15482,14 @@
         </p:nvSpPr>
         <p:spPr>
           <a:xfrm>
-            <a:off x="450000" y="3075720"/>
-            <a:ext cx="4008560" cy="560000"/>
+            <a:off x="450000" y="3360000"/>
+            <a:ext cx="3850000" cy="870000"/>
           </a:xfrm>
           <a:prstGeom prst="rect">
             <a:avLst/>
           </a:prstGeom>
           <a:solidFill>
-            <a:srgbClr val="2C3E50"/>
+            <a:srgbClr val="1A1A1A"/>
           </a:solidFill>
           <a:ln>
             <a:noFill/>
@@ -15496,39 +15515,39 @@
           <a:p>
             <a:pPr algn="l">
               <a:spcBef>
-                <a:spcPts val="600"/>
+                <a:spcPts val="1000"/>
               </a:spcBef>
               <a:spcAft>
-                <a:spcPts val="0"/>
+                <a:spcPts val="100"/>
               </a:spcAft>
             </a:pPr>
             <a:r>
-              <a:rPr sz="1200" b="1">
+              <a:rPr sz="1300" b="1">
                 <a:solidFill>
                   <a:srgbClr val="FFFFFF"/>
                 </a:solidFill>
                 <a:latin typeface="맑은 고딕"/>
               </a:rPr>
-              <a:t>② Mid-Market</a:t>
+              <a:t>②  Mid-Market</a:t>
             </a:r>
           </a:p>
           <a:p>
             <a:pPr algn="l">
               <a:spcBef>
-                <a:spcPts val="200"/>
+                <a:spcPts val="400"/>
               </a:spcBef>
               <a:spcAft>
-                <a:spcPts val="0"/>
+                <a:spcPts val="100"/>
               </a:spcAft>
             </a:pPr>
             <a:r>
-              <a:rPr sz="1000" b="0">
-                <a:solidFill>
-                  <a:srgbClr val="AACCFF"/>
+              <a:rPr sz="1100" b="0">
+                <a:solidFill>
+                  <a:srgbClr val="BBCCFF"/>
                 </a:solidFill>
                 <a:latin typeface="맑은 고딕"/>
               </a:rPr>
-              <a:t>Model 3 / Y</a:t>
+              <a:t>Model 3  /  Y</a:t>
             </a:r>
           </a:p>
           <a:p>
@@ -15537,17 +15556,36 @@
                 <a:spcPts val="300"/>
               </a:spcBef>
               <a:spcAft>
-                <a:spcPts val="0"/>
+                <a:spcPts val="100"/>
               </a:spcAft>
             </a:pPr>
             <a:r>
-              <a:rPr sz="900" b="0">
-                <a:solidFill>
-                  <a:srgbClr val="DDDDDD"/>
+              <a:rPr sz="1100" b="0">
+                <a:solidFill>
+                  <a:srgbClr val="BBCCFF"/>
                 </a:solidFill>
                 <a:latin typeface="맑은 고딕"/>
               </a:rPr>
-              <a:t>중산층 실용 프리미엄 — TCO 절감 메시지</a:t>
+              <a:t>대상  :  중산층 ($50K~$100K)</a:t>
+            </a:r>
+          </a:p>
+          <a:p>
+            <a:pPr algn="l">
+              <a:spcBef>
+                <a:spcPts val="300"/>
+              </a:spcBef>
+              <a:spcAft>
+                <a:spcPts val="100"/>
+              </a:spcAft>
+            </a:pPr>
+            <a:r>
+              <a:rPr sz="1100" b="0">
+                <a:solidFill>
+                  <a:srgbClr val="BBCCFF"/>
+                </a:solidFill>
+                <a:latin typeface="맑은 고딕"/>
+              </a:rPr>
+              <a:t>전략  :  실용 프리미엄 — TCO 절감 메시지</a:t>
             </a:r>
           </a:p>
         </p:txBody>
@@ -15560,8 +15598,8 @@
         </p:nvSpPr>
         <p:spPr>
           <a:xfrm>
-            <a:off x="450000" y="3658580"/>
-            <a:ext cx="4008560" cy="560000"/>
+            <a:off x="450000" y="4270000"/>
+            <a:ext cx="3850000" cy="870000"/>
           </a:xfrm>
           <a:prstGeom prst="rect">
             <a:avLst/>
@@ -15593,39 +15631,39 @@
           <a:p>
             <a:pPr algn="l">
               <a:spcBef>
-                <a:spcPts val="600"/>
+                <a:spcPts val="1000"/>
               </a:spcBef>
               <a:spcAft>
-                <a:spcPts val="0"/>
+                <a:spcPts val="100"/>
               </a:spcAft>
             </a:pPr>
             <a:r>
-              <a:rPr sz="1200" b="1">
+              <a:rPr sz="1300" b="1">
                 <a:solidFill>
                   <a:srgbClr val="FFFFFF"/>
                 </a:solidFill>
                 <a:latin typeface="맑은 고딕"/>
               </a:rPr>
-              <a:t>③ Mass Market</a:t>
+              <a:t>③  Mass Market  (신규)</a:t>
             </a:r>
           </a:p>
           <a:p>
             <a:pPr algn="l">
               <a:spcBef>
-                <a:spcPts val="200"/>
+                <a:spcPts val="400"/>
               </a:spcBef>
               <a:spcAft>
-                <a:spcPts val="0"/>
+                <a:spcPts val="100"/>
               </a:spcAft>
             </a:pPr>
             <a:r>
-              <a:rPr sz="1000" b="0">
-                <a:solidFill>
-                  <a:srgbClr val="AACCFF"/>
+              <a:rPr sz="1100" b="0">
+                <a:solidFill>
+                  <a:srgbClr val="CCEEFF"/>
                 </a:solidFill>
                 <a:latin typeface="맑은 고딕"/>
               </a:rPr>
-              <a:t>보급형 $25K↓ (신규)</a:t>
+              <a:t>보급형  $25,000↓</a:t>
             </a:r>
           </a:p>
           <a:p>
@@ -15634,17 +15672,36 @@
                 <a:spcPts val="300"/>
               </a:spcBef>
               <a:spcAft>
-                <a:spcPts val="0"/>
+                <a:spcPts val="100"/>
               </a:spcAft>
             </a:pPr>
             <a:r>
-              <a:rPr sz="900" b="0">
-                <a:solidFill>
-                  <a:srgbClr val="DDDDDD"/>
+              <a:rPr sz="1100" b="0">
+                <a:solidFill>
+                  <a:srgbClr val="CCEEFF"/>
                 </a:solidFill>
                 <a:latin typeface="맑은 고딕"/>
               </a:rPr>
-              <a:t>Apple SE 전략 — 작지만 완벽한 Tesla</a:t>
+              <a:t>대상  :  저·중소득층 / 다양한 고객군</a:t>
+            </a:r>
+          </a:p>
+          <a:p>
+            <a:pPr algn="l">
+              <a:spcBef>
+                <a:spcPts val="300"/>
+              </a:spcBef>
+              <a:spcAft>
+                <a:spcPts val="100"/>
+              </a:spcAft>
+            </a:pPr>
+            <a:r>
+              <a:rPr sz="1100" b="0">
+                <a:solidFill>
+                  <a:srgbClr val="CCEEFF"/>
+                </a:solidFill>
+                <a:latin typeface="맑은 고딕"/>
+              </a:rPr>
+              <a:t>전략  :  Apple SE 방식 — 작지만 완벽한 Tesla</a:t>
             </a:r>
           </a:p>
         </p:txBody>
@@ -15657,8 +15714,8 @@
         </p:nvSpPr>
         <p:spPr>
           <a:xfrm>
-            <a:off x="4550000" y="2100000"/>
-            <a:ext cx="4008560" cy="370000"/>
+            <a:off x="4400000" y="2090000"/>
+            <a:ext cx="4100000" cy="340000"/>
           </a:xfrm>
           <a:prstGeom prst="rect">
             <a:avLst/>
@@ -15690,10 +15747,10 @@
           <a:p>
             <a:pPr algn="l">
               <a:spcBef>
-                <a:spcPts val="400"/>
+                <a:spcPts val="700"/>
               </a:spcBef>
               <a:spcAft>
-                <a:spcPts val="0"/>
+                <a:spcPts val="100"/>
               </a:spcAft>
             </a:pPr>
             <a:r>
@@ -15703,7 +15760,7 @@
                 </a:solidFill>
                 <a:latin typeface="맑은 고딕"/>
               </a:rPr>
-              <a:t>▸ 마케팅 전략 : 4가지 실행 방향</a:t>
+              <a:t>▸  마케팅 전략 : 4가지 실행 방향</a:t>
             </a:r>
           </a:p>
         </p:txBody>
@@ -15716,8 +15773,8 @@
         </p:nvSpPr>
         <p:spPr>
           <a:xfrm>
-            <a:off x="4550000" y="2492860"/>
-            <a:ext cx="4008560" cy="480000"/>
+            <a:off x="4400000" y="2450000"/>
+            <a:ext cx="4100000" cy="730000"/>
           </a:xfrm>
           <a:prstGeom prst="rect">
             <a:avLst/>
@@ -15749,43 +15806,77 @@
           <a:p>
             <a:pPr algn="l">
               <a:spcBef>
-                <a:spcPts val="600"/>
+                <a:spcPts val="800"/>
               </a:spcBef>
               <a:spcAft>
-                <a:spcPts val="200"/>
+                <a:spcPts val="100"/>
               </a:spcAft>
             </a:pPr>
             <a:r>
-              <a:rPr sz="1100" b="1">
+              <a:rPr sz="1200" b="1">
                 <a:solidFill>
                   <a:srgbClr val="FFFFFF"/>
                 </a:solidFill>
                 <a:latin typeface="맑은 고딕"/>
               </a:rPr>
-              <a:t>① 세그먼트별 메시지 분리</a:t>
+              <a:t>①  세그먼트별 메시지 분리</a:t>
             </a:r>
           </a:p>
           <a:p>
             <a:pPr algn="l">
               <a:spcBef>
-                <a:spcPts val="200"/>
+                <a:spcPts val="300"/>
               </a:spcBef>
               <a:spcAft>
-                <a:spcPts val="0"/>
+                <a:spcPts val="100"/>
               </a:spcAft>
             </a:pPr>
             <a:r>
-              <a:rPr sz="900" b="0">
-                <a:solidFill>
-                  <a:srgbClr val="DDDDDD"/>
+              <a:rPr sz="1000" b="0">
+                <a:solidFill>
+                  <a:srgbClr val="EEEEEE"/>
                 </a:solidFill>
                 <a:latin typeface="맑은 고딕"/>
               </a:rPr>
-              <a:t>고소득 → 기술·혁신·지위재  /  중산층 → TCO 절감</a:t>
-            </a:r>
-            <a:br/>
-            <a:r>
-              <a:t>저소득 → IRA 보조금 $7,500 + 연료비 절약 강조</a:t>
+              <a:t>• 고소득층  →  기술 · 혁신 · 지위재 강조</a:t>
+            </a:r>
+          </a:p>
+          <a:p>
+            <a:pPr algn="l">
+              <a:spcBef>
+                <a:spcPts val="300"/>
+              </a:spcBef>
+              <a:spcAft>
+                <a:spcPts val="100"/>
+              </a:spcAft>
+            </a:pPr>
+            <a:r>
+              <a:rPr sz="1000" b="0">
+                <a:solidFill>
+                  <a:srgbClr val="EEEEEE"/>
+                </a:solidFill>
+                <a:latin typeface="맑은 고딕"/>
+              </a:rPr>
+              <a:t>• 중산층    →  TCO 절감 (5년 후 휘발유차보다 저렴)</a:t>
+            </a:r>
+          </a:p>
+          <a:p>
+            <a:pPr algn="l">
+              <a:spcBef>
+                <a:spcPts val="300"/>
+              </a:spcBef>
+              <a:spcAft>
+                <a:spcPts val="100"/>
+              </a:spcAft>
+            </a:pPr>
+            <a:r>
+              <a:rPr sz="1000" b="0">
+                <a:solidFill>
+                  <a:srgbClr val="EEEEEE"/>
+                </a:solidFill>
+                <a:latin typeface="맑은 고딕"/>
+              </a:rPr>
+              <a:t>• 저소득층  →  IRA 보조금 $7,500 + 연료비 절약 전면 강조</a:t>
             </a:r>
           </a:p>
         </p:txBody>
@@ -15798,14 +15889,14 @@
         </p:nvSpPr>
         <p:spPr>
           <a:xfrm>
-            <a:off x="4550000" y="2995720"/>
-            <a:ext cx="4008560" cy="480000"/>
+            <a:off x="4400000" y="3240000"/>
+            <a:ext cx="4100000" cy="730000"/>
           </a:xfrm>
           <a:prstGeom prst="rect">
             <a:avLst/>
           </a:prstGeom>
           <a:solidFill>
-            <a:srgbClr val="3D3D3D"/>
+            <a:srgbClr val="2C3E50"/>
           </a:solidFill>
           <a:ln>
             <a:noFill/>
@@ -15831,43 +15922,77 @@
           <a:p>
             <a:pPr algn="l">
               <a:spcBef>
-                <a:spcPts val="600"/>
+                <a:spcPts val="800"/>
               </a:spcBef>
               <a:spcAft>
-                <a:spcPts val="200"/>
+                <a:spcPts val="100"/>
               </a:spcAft>
             </a:pPr>
             <a:r>
-              <a:rPr sz="1100" b="1">
+              <a:rPr sz="1200" b="1">
                 <a:solidFill>
                   <a:srgbClr val="FFFFFF"/>
                 </a:solidFill>
                 <a:latin typeface="맑은 고딕"/>
               </a:rPr>
-              <a:t>② 유통 채널 다각화</a:t>
+              <a:t>②  유통 채널 다각화</a:t>
             </a:r>
           </a:p>
           <a:p>
             <a:pPr algn="l">
               <a:spcBef>
-                <a:spcPts val="200"/>
+                <a:spcPts val="300"/>
               </a:spcBef>
               <a:spcAft>
-                <a:spcPts val="0"/>
+                <a:spcPts val="100"/>
               </a:spcAft>
             </a:pPr>
             <a:r>
-              <a:rPr sz="900" b="0">
-                <a:solidFill>
-                  <a:srgbClr val="DDDDDD"/>
+              <a:rPr sz="1000" b="0">
+                <a:solidFill>
+                  <a:srgbClr val="EEEEEE"/>
                 </a:solidFill>
                 <a:latin typeface="맑은 고딕"/>
               </a:rPr>
-              <a:t>직영 온라인 + 쇼룸 유지</a:t>
-            </a:r>
-            <a:br/>
-            <a:r>
-              <a:t>농촌·교외 서비스센터 확대 — 충전 인프라 先 투자</a:t>
+              <a:t>• 직영 온라인 + 직영 쇼룸 유지</a:t>
+            </a:r>
+          </a:p>
+          <a:p>
+            <a:pPr algn="l">
+              <a:spcBef>
+                <a:spcPts val="300"/>
+              </a:spcBef>
+              <a:spcAft>
+                <a:spcPts val="100"/>
+              </a:spcAft>
+            </a:pPr>
+            <a:r>
+              <a:rPr sz="1000" b="0">
+                <a:solidFill>
+                  <a:srgbClr val="EEEEEE"/>
+                </a:solidFill>
+                <a:latin typeface="맑은 고딕"/>
+              </a:rPr>
+              <a:t>• 농촌 · 교외 서비스센터 단계적 확대</a:t>
+            </a:r>
+          </a:p>
+          <a:p>
+            <a:pPr algn="l">
+              <a:spcBef>
+                <a:spcPts val="300"/>
+              </a:spcBef>
+              <a:spcAft>
+                <a:spcPts val="100"/>
+              </a:spcAft>
+            </a:pPr>
+            <a:r>
+              <a:rPr sz="1000" b="0">
+                <a:solidFill>
+                  <a:srgbClr val="EEEEEE"/>
+                </a:solidFill>
+                <a:latin typeface="맑은 고딕"/>
+              </a:rPr>
+              <a:t>• 충전 인프라 선(先) 투자 후 차량 판매 전략</a:t>
             </a:r>
           </a:p>
         </p:txBody>
@@ -15880,14 +16005,14 @@
         </p:nvSpPr>
         <p:spPr>
           <a:xfrm>
-            <a:off x="4550000" y="3498580"/>
-            <a:ext cx="4008560" cy="480000"/>
+            <a:off x="4400000" y="4030000"/>
+            <a:ext cx="4100000" cy="730000"/>
           </a:xfrm>
           <a:prstGeom prst="rect">
             <a:avLst/>
           </a:prstGeom>
           <a:solidFill>
-            <a:srgbClr val="3D3D3D"/>
+            <a:srgbClr val="555555"/>
           </a:solidFill>
           <a:ln>
             <a:noFill/>
@@ -15913,43 +16038,77 @@
           <a:p>
             <a:pPr algn="l">
               <a:spcBef>
-                <a:spcPts val="600"/>
+                <a:spcPts val="800"/>
               </a:spcBef>
               <a:spcAft>
-                <a:spcPts val="200"/>
+                <a:spcPts val="100"/>
               </a:spcAft>
             </a:pPr>
             <a:r>
-              <a:rPr sz="1100" b="1">
+              <a:rPr sz="1200" b="1">
                 <a:solidFill>
                   <a:srgbClr val="FFFFFF"/>
                 </a:solidFill>
                 <a:latin typeface="맑은 고딕"/>
               </a:rPr>
-              <a:t>③ 금융 접근성 강화</a:t>
+              <a:t>③  금융 접근성 강화</a:t>
             </a:r>
           </a:p>
           <a:p>
             <a:pPr algn="l">
               <a:spcBef>
-                <a:spcPts val="200"/>
+                <a:spcPts val="300"/>
               </a:spcBef>
               <a:spcAft>
-                <a:spcPts val="0"/>
+                <a:spcPts val="100"/>
               </a:spcAft>
             </a:pPr>
             <a:r>
-              <a:rPr sz="900" b="0">
-                <a:solidFill>
-                  <a:srgbClr val="DDDDDD"/>
+              <a:rPr sz="1000" b="0">
+                <a:solidFill>
+                  <a:srgbClr val="EEEEEE"/>
                 </a:solidFill>
                 <a:latin typeface="맑은 고딕"/>
               </a:rPr>
-              <a:t>리스(Lease) 프로그램 / 인증 중고(CPO) 시장</a:t>
-            </a:r>
-            <a:br/>
-            <a:r>
-              <a:t>IRA 세액공제 POS 즉시 적용 시스템 구축</a:t>
+              <a:t>• 리스(Lease) 프로그램 확대 — 초기 비용 부담 완화</a:t>
+            </a:r>
+          </a:p>
+          <a:p>
+            <a:pPr algn="l">
+              <a:spcBef>
+                <a:spcPts val="300"/>
+              </a:spcBef>
+              <a:spcAft>
+                <a:spcPts val="100"/>
+              </a:spcAft>
+            </a:pPr>
+            <a:r>
+              <a:rPr sz="1000" b="0">
+                <a:solidFill>
+                  <a:srgbClr val="EEEEEE"/>
+                </a:solidFill>
+                <a:latin typeface="맑은 고딕"/>
+              </a:rPr>
+              <a:t>• 인증 중고(CPO) 시장 활성화</a:t>
+            </a:r>
+          </a:p>
+          <a:p>
+            <a:pPr algn="l">
+              <a:spcBef>
+                <a:spcPts val="300"/>
+              </a:spcBef>
+              <a:spcAft>
+                <a:spcPts val="100"/>
+              </a:spcAft>
+            </a:pPr>
+            <a:r>
+              <a:rPr sz="1000" b="0">
+                <a:solidFill>
+                  <a:srgbClr val="EEEEEE"/>
+                </a:solidFill>
+                <a:latin typeface="맑은 고딕"/>
+              </a:rPr>
+              <a:t>• IRA 세액공제 $7,500 구매 시점 즉시 적용</a:t>
             </a:r>
           </a:p>
         </p:txBody>
@@ -15962,14 +16121,14 @@
         </p:nvSpPr>
         <p:spPr>
           <a:xfrm>
-            <a:off x="4550000" y="4001440"/>
-            <a:ext cx="4008560" cy="480000"/>
+            <a:off x="4400000" y="4820000"/>
+            <a:ext cx="4100000" cy="730000"/>
           </a:xfrm>
           <a:prstGeom prst="rect">
             <a:avLst/>
           </a:prstGeom>
           <a:solidFill>
-            <a:srgbClr val="2C3E50"/>
+            <a:srgbClr val="1E8B4C"/>
           </a:solidFill>
           <a:ln>
             <a:noFill/>
@@ -15995,43 +16154,77 @@
           <a:p>
             <a:pPr algn="l">
               <a:spcBef>
-                <a:spcPts val="600"/>
+                <a:spcPts val="800"/>
               </a:spcBef>
               <a:spcAft>
-                <a:spcPts val="200"/>
+                <a:spcPts val="100"/>
               </a:spcAft>
             </a:pPr>
             <a:r>
-              <a:rPr sz="1100" b="1">
+              <a:rPr sz="1200" b="1">
                 <a:solidFill>
                   <a:srgbClr val="FFFFFF"/>
                 </a:solidFill>
                 <a:latin typeface="맑은 고딕"/>
               </a:rPr>
-              <a:t>④ 커뮤니티 파트너십</a:t>
+              <a:t>④  커뮤니티 파트너십</a:t>
             </a:r>
           </a:p>
           <a:p>
             <a:pPr algn="l">
               <a:spcBef>
-                <a:spcPts val="200"/>
+                <a:spcPts val="300"/>
               </a:spcBef>
               <a:spcAft>
-                <a:spcPts val="0"/>
+                <a:spcPts val="100"/>
               </a:spcAft>
             </a:pPr>
             <a:r>
-              <a:rPr sz="900" b="0">
-                <a:solidFill>
-                  <a:srgbClr val="DDDDDD"/>
+              <a:rPr sz="1000" b="0">
+                <a:solidFill>
+                  <a:srgbClr val="EEEEEE"/>
                 </a:solidFill>
                 <a:latin typeface="맑은 고딕"/>
               </a:rPr>
-              <a:t>비영리단체·CDFI와 저소득 커뮤니티 접근</a:t>
-            </a:r>
-            <a:br/>
-            <a:r>
-              <a:t>지역 체험·시승 프로그램 → 신뢰 구축</a:t>
+              <a:t>• 비영리단체 · CDFI와 저소득 커뮤니티 접근</a:t>
+            </a:r>
+          </a:p>
+          <a:p>
+            <a:pPr algn="l">
+              <a:spcBef>
+                <a:spcPts val="300"/>
+              </a:spcBef>
+              <a:spcAft>
+                <a:spcPts val="100"/>
+              </a:spcAft>
+            </a:pPr>
+            <a:r>
+              <a:rPr sz="1000" b="0">
+                <a:solidFill>
+                  <a:srgbClr val="EEEEEE"/>
+                </a:solidFill>
+                <a:latin typeface="맑은 고딕"/>
+              </a:rPr>
+              <a:t>• 지역 체험 · 시승 프로그램으로 신뢰 구축</a:t>
+            </a:r>
+          </a:p>
+          <a:p>
+            <a:pPr algn="l">
+              <a:spcBef>
+                <a:spcPts val="300"/>
+              </a:spcBef>
+              <a:spcAft>
+                <a:spcPts val="100"/>
+              </a:spcAft>
+            </a:pPr>
+            <a:r>
+              <a:rPr sz="1000" b="0">
+                <a:solidFill>
+                  <a:srgbClr val="EEEEEE"/>
+                </a:solidFill>
+                <a:latin typeface="맑은 고딕"/>
+              </a:rPr>
+              <a:t>• 다양성 반영 마케팅 — 현재 타겟과 다른 고객 공감</a:t>
             </a:r>
           </a:p>
         </p:txBody>
@@ -16044,16 +16237,16 @@
         </p:nvSpPr>
         <p:spPr>
           <a:xfrm>
-            <a:off x="450000" y="4321440"/>
-            <a:ext cx="8108560" cy="320000"/>
+            <a:off x="450000" y="5240000"/>
+            <a:ext cx="8200000" cy="320000"/>
           </a:xfrm>
           <a:prstGeom prst="rect">
             <a:avLst/>
           </a:prstGeom>
           <a:solidFill>
-            <a:srgbClr val="F9F2EC"/>
-          </a:solidFill>
-          <a:ln w="9525">
+            <a:srgbClr val="F5F0E8"/>
+          </a:solidFill>
+          <a:ln w="12700">
             <a:solidFill>
               <a:srgbClr val="E31937"/>
             </a:solidFill>
@@ -16082,7 +16275,7 @@
                 <a:spcPts val="800"/>
               </a:spcBef>
               <a:spcAft>
-                <a:spcPts val="0"/>
+                <a:spcPts val="100"/>
               </a:spcAft>
             </a:pPr>
             <a:r>
@@ -16388,8 +16581,8 @@
         </p:nvSpPr>
         <p:spPr>
           <a:xfrm>
-            <a:off x="430000" y="1900000"/>
-            <a:ext cx="1596000" cy="4100000"/>
+            <a:off x="450000" y="1870000"/>
+            <a:ext cx="2686666" cy="2100000"/>
           </a:xfrm>
           <a:prstGeom prst="rect">
             <a:avLst/>
@@ -16419,12 +16612,12 @@
           <a:bodyPr rtlCol="0" anchor="ctr" wrap="square"/>
           <a:lstStyle/>
           <a:p>
-            <a:pPr algn="ctr">
+            <a:pPr algn="l">
               <a:spcBef>
-                <a:spcPts val="1200"/>
+                <a:spcPts val="1000"/>
               </a:spcBef>
               <a:spcAft>
-                <a:spcPts val="600"/>
+                <a:spcPts val="100"/>
               </a:spcAft>
             </a:pPr>
             <a:r>
@@ -16434,42 +16627,102 @@
                 </a:solidFill>
                 <a:latin typeface="맑은 고딕"/>
               </a:rPr>
-              <a:t>① 저비용</a:t>
-            </a:r>
-            <a:br/>
-            <a:r>
-              <a:t>제조 역량</a:t>
+              <a:t>①  저비용 제조 역량</a:t>
             </a:r>
           </a:p>
           <a:p>
             <a:pPr algn="l">
               <a:spcBef>
-                <a:spcPts val="600"/>
+                <a:spcPts val="300"/>
               </a:spcBef>
               <a:spcAft>
-                <a:spcPts val="200"/>
+                <a:spcPts val="100"/>
               </a:spcAft>
             </a:pPr>
             <a:r>
-              <a:rPr sz="900" b="0">
+              <a:rPr sz="1000" b="0">
+                <a:solidFill>
+                  <a:srgbClr val="FFEEAA"/>
+                </a:solidFill>
+                <a:latin typeface="맑은 고딕"/>
+              </a:rPr>
+              <a:t>목표: $25K EV 수익성 확보</a:t>
+            </a:r>
+          </a:p>
+          <a:p>
+            <a:pPr algn="l">
+              <a:spcBef>
+                <a:spcPts val="400"/>
+              </a:spcBef>
+              <a:spcAft>
+                <a:spcPts val="100"/>
+              </a:spcAft>
+            </a:pPr>
+            <a:r>
+              <a:rPr sz="1000" b="0">
                 <a:solidFill>
                   <a:srgbClr val="EEEEEE"/>
                 </a:solidFill>
                 <a:latin typeface="맑은 고딕"/>
               </a:rPr>
-              <a:t>4680 배터리 양산 가속</a:t>
-            </a:r>
-            <a:br/>
-            <a:r>
-              <a:t>플랫폼 부품 수 최소화</a:t>
-            </a:r>
-            <a:br/>
-            <a:r>
-              <a:t>기가팩토리 수율 극대화</a:t>
-            </a:r>
-            <a:br/>
-            <a:r>
-              <a:t>→ 목표: $25K EV 수익성</a:t>
+              <a:t>• 4680 배터리 셀 양산 원가 절감 가속화</a:t>
+            </a:r>
+          </a:p>
+          <a:p>
+            <a:pPr algn="l">
+              <a:spcBef>
+                <a:spcPts val="400"/>
+              </a:spcBef>
+              <a:spcAft>
+                <a:spcPts val="100"/>
+              </a:spcAft>
+            </a:pPr>
+            <a:r>
+              <a:rPr sz="1000" b="0">
+                <a:solidFill>
+                  <a:srgbClr val="EEEEEE"/>
+                </a:solidFill>
+                <a:latin typeface="맑은 고딕"/>
+              </a:rPr>
+              <a:t>• 차량 플랫폼 단순화 — 부품 수 최소화</a:t>
+            </a:r>
+          </a:p>
+          <a:p>
+            <a:pPr algn="l">
+              <a:spcBef>
+                <a:spcPts val="400"/>
+              </a:spcBef>
+              <a:spcAft>
+                <a:spcPts val="100"/>
+              </a:spcAft>
+            </a:pPr>
+            <a:r>
+              <a:rPr sz="1000" b="0">
+                <a:solidFill>
+                  <a:srgbClr val="EEEEEE"/>
+                </a:solidFill>
+                <a:latin typeface="맑은 고딕"/>
+              </a:rPr>
+              <a:t>• 기가팩토리 생산 수율(Yield) 극대화</a:t>
+            </a:r>
+          </a:p>
+          <a:p>
+            <a:pPr algn="l">
+              <a:spcBef>
+                <a:spcPts val="400"/>
+              </a:spcBef>
+              <a:spcAft>
+                <a:spcPts val="100"/>
+              </a:spcAft>
+            </a:pPr>
+            <a:r>
+              <a:rPr sz="1000" b="0">
+                <a:solidFill>
+                  <a:srgbClr val="EEEEEE"/>
+                </a:solidFill>
+                <a:latin typeface="맑은 고딕"/>
+              </a:rPr>
+              <a:t>• BYD처럼 배터리 수직계열화 심화</a:t>
             </a:r>
           </a:p>
         </p:txBody>
@@ -16482,14 +16735,14 @@
         </p:nvSpPr>
         <p:spPr>
           <a:xfrm>
-            <a:off x="2106000" y="1900000"/>
-            <a:ext cx="1596000" cy="4100000"/>
+            <a:off x="3206666" y="1870000"/>
+            <a:ext cx="2686666" cy="2100000"/>
           </a:xfrm>
           <a:prstGeom prst="rect">
             <a:avLst/>
           </a:prstGeom>
           <a:solidFill>
-            <a:srgbClr val="2C3E50"/>
+            <a:srgbClr val="164F96"/>
           </a:solidFill>
           <a:ln>
             <a:noFill/>
@@ -16513,12 +16766,12 @@
           <a:bodyPr rtlCol="0" anchor="ctr" wrap="square"/>
           <a:lstStyle/>
           <a:p>
-            <a:pPr algn="ctr">
+            <a:pPr algn="l">
               <a:spcBef>
-                <a:spcPts val="1200"/>
+                <a:spcPts val="1000"/>
               </a:spcBef>
               <a:spcAft>
-                <a:spcPts val="600"/>
+                <a:spcPts val="100"/>
               </a:spcAft>
             </a:pPr>
             <a:r>
@@ -16528,42 +16781,102 @@
                 </a:solidFill>
                 <a:latin typeface="맑은 고딕"/>
               </a:rPr>
-              <a:t>② 충전 인프라</a:t>
-            </a:r>
-            <a:br/>
-            <a:r>
-              <a:t>확장</a:t>
+              <a:t>②  충전 인프라 확장</a:t>
             </a:r>
           </a:p>
           <a:p>
             <a:pPr algn="l">
               <a:spcBef>
-                <a:spcPts val="600"/>
+                <a:spcPts val="300"/>
               </a:spcBef>
               <a:spcAft>
-                <a:spcPts val="200"/>
+                <a:spcPts val="100"/>
               </a:spcAft>
             </a:pPr>
             <a:r>
-              <a:rPr sz="900" b="0">
+              <a:rPr sz="1000" b="0">
+                <a:solidFill>
+                  <a:srgbClr val="FFEEAA"/>
+                </a:solidFill>
+                <a:latin typeface="맑은 고딕"/>
+              </a:rPr>
+              <a:t>Charging Desert 해소가 선결 과제</a:t>
+            </a:r>
+          </a:p>
+          <a:p>
+            <a:pPr algn="l">
+              <a:spcBef>
+                <a:spcPts val="400"/>
+              </a:spcBef>
+              <a:spcAft>
+                <a:spcPts val="100"/>
+              </a:spcAft>
+            </a:pPr>
+            <a:r>
+              <a:rPr sz="1000" b="0">
                 <a:solidFill>
                   <a:srgbClr val="EEEEEE"/>
                 </a:solidFill>
                 <a:latin typeface="맑은 고딕"/>
               </a:rPr>
-              <a:t>농촌·교외 Supercharger</a:t>
-            </a:r>
-            <a:br/>
-            <a:r>
-              <a:t>NACS 개방으로 수익화</a:t>
-            </a:r>
-            <a:br/>
-            <a:r>
-              <a:t>V2G 상용화 추진</a:t>
-            </a:r>
-            <a:br/>
-            <a:r>
-              <a:t>무선충전 R&amp;D 투자</a:t>
+              <a:t>• 농촌 · 교외 Supercharger 네트워크 확장</a:t>
+            </a:r>
+          </a:p>
+          <a:p>
+            <a:pPr algn="l">
+              <a:spcBef>
+                <a:spcPts val="400"/>
+              </a:spcBef>
+              <a:spcAft>
+                <a:spcPts val="100"/>
+              </a:spcAft>
+            </a:pPr>
+            <a:r>
+              <a:rPr sz="1000" b="0">
+                <a:solidFill>
+                  <a:srgbClr val="EEEEEE"/>
+                </a:solidFill>
+                <a:latin typeface="맑은 고딕"/>
+              </a:rPr>
+              <a:t>• NACS 개방 → 타사 충전 수익화</a:t>
+            </a:r>
+          </a:p>
+          <a:p>
+            <a:pPr algn="l">
+              <a:spcBef>
+                <a:spcPts val="400"/>
+              </a:spcBef>
+              <a:spcAft>
+                <a:spcPts val="100"/>
+              </a:spcAft>
+            </a:pPr>
+            <a:r>
+              <a:rPr sz="1000" b="0">
+                <a:solidFill>
+                  <a:srgbClr val="EEEEEE"/>
+                </a:solidFill>
+                <a:latin typeface="맑은 고딕"/>
+              </a:rPr>
+              <a:t>• V2G(차량→전력망) 기술 상용화</a:t>
+            </a:r>
+          </a:p>
+          <a:p>
+            <a:pPr algn="l">
+              <a:spcBef>
+                <a:spcPts val="400"/>
+              </a:spcBef>
+              <a:spcAft>
+                <a:spcPts val="100"/>
+              </a:spcAft>
+            </a:pPr>
+            <a:r>
+              <a:rPr sz="1000" b="0">
+                <a:solidFill>
+                  <a:srgbClr val="EEEEEE"/>
+                </a:solidFill>
+                <a:latin typeface="맑은 고딕"/>
+              </a:rPr>
+              <a:t>• 무선충전 R&amp;D (WiTricity 등 파트너십)</a:t>
             </a:r>
           </a:p>
         </p:txBody>
@@ -16576,14 +16889,14 @@
         </p:nvSpPr>
         <p:spPr>
           <a:xfrm>
-            <a:off x="3782000" y="1900000"/>
-            <a:ext cx="1596000" cy="4100000"/>
+            <a:off x="5963332" y="1870000"/>
+            <a:ext cx="2686666" cy="2100000"/>
           </a:xfrm>
           <a:prstGeom prst="rect">
             <a:avLst/>
           </a:prstGeom>
           <a:solidFill>
-            <a:srgbClr val="164F96"/>
+            <a:srgbClr val="2C3E50"/>
           </a:solidFill>
           <a:ln>
             <a:noFill/>
@@ -16607,12 +16920,12 @@
           <a:bodyPr rtlCol="0" anchor="ctr" wrap="square"/>
           <a:lstStyle/>
           <a:p>
-            <a:pPr algn="ctr">
+            <a:pPr algn="l">
               <a:spcBef>
-                <a:spcPts val="1200"/>
+                <a:spcPts val="1000"/>
               </a:spcBef>
               <a:spcAft>
-                <a:spcPts val="600"/>
+                <a:spcPts val="100"/>
               </a:spcAft>
             </a:pPr>
             <a:r>
@@ -16622,42 +16935,102 @@
                 </a:solidFill>
                 <a:latin typeface="맑은 고딕"/>
               </a:rPr>
-              <a:t>③ 금융·접근성</a:t>
-            </a:r>
-            <a:br/>
-            <a:r>
-              <a:t>서비스</a:t>
+              <a:t>③  금융 · 접근성 서비스</a:t>
             </a:r>
           </a:p>
           <a:p>
             <a:pPr algn="l">
               <a:spcBef>
-                <a:spcPts val="600"/>
+                <a:spcPts val="300"/>
               </a:spcBef>
               <a:spcAft>
-                <a:spcPts val="200"/>
+                <a:spcPts val="100"/>
               </a:spcAft>
             </a:pPr>
             <a:r>
-              <a:rPr sz="900" b="0">
+              <a:rPr sz="1000" b="0">
+                <a:solidFill>
+                  <a:srgbClr val="FFEEAA"/>
+                </a:solidFill>
+                <a:latin typeface="맑은 고딕"/>
+              </a:rPr>
+              <a:t>살 수 있는 조건을 만드는 역량</a:t>
+            </a:r>
+          </a:p>
+          <a:p>
+            <a:pPr algn="l">
+              <a:spcBef>
+                <a:spcPts val="400"/>
+              </a:spcBef>
+              <a:spcAft>
+                <a:spcPts val="100"/>
+              </a:spcAft>
+            </a:pPr>
+            <a:r>
+              <a:rPr sz="1000" b="0">
                 <a:solidFill>
                   <a:srgbClr val="EEEEEE"/>
                 </a:solidFill>
                 <a:latin typeface="맑은 고딕"/>
               </a:rPr>
-              <a:t>리스 프로그램 확대</a:t>
-            </a:r>
-            <a:br/>
-            <a:r>
-              <a:t>인증 중고(CPO) 강화</a:t>
-            </a:r>
-            <a:br/>
-            <a:r>
-              <a:t>저신용 파이낸싱</a:t>
-            </a:r>
-            <a:br/>
-            <a:r>
-              <a:t>IRA $7,500 즉시 적용</a:t>
+              <a:t>• 리스(Lease) 프로그램 대폭 확대</a:t>
+            </a:r>
+          </a:p>
+          <a:p>
+            <a:pPr algn="l">
+              <a:spcBef>
+                <a:spcPts val="400"/>
+              </a:spcBef>
+              <a:spcAft>
+                <a:spcPts val="100"/>
+              </a:spcAft>
+            </a:pPr>
+            <a:r>
+              <a:rPr sz="1000" b="0">
+                <a:solidFill>
+                  <a:srgbClr val="EEEEEE"/>
+                </a:solidFill>
+                <a:latin typeface="맑은 고딕"/>
+              </a:rPr>
+              <a:t>• 인증 중고(CPO) — 저가 진입 경로 제공</a:t>
+            </a:r>
+          </a:p>
+          <a:p>
+            <a:pPr algn="l">
+              <a:spcBef>
+                <a:spcPts val="400"/>
+              </a:spcBef>
+              <a:spcAft>
+                <a:spcPts val="100"/>
+              </a:spcAft>
+            </a:pPr>
+            <a:r>
+              <a:rPr sz="1000" b="0">
+                <a:solidFill>
+                  <a:srgbClr val="EEEEEE"/>
+                </a:solidFill>
+                <a:latin typeface="맑은 고딕"/>
+              </a:rPr>
+              <a:t>• 저신용층 파이낸싱 (CDFI 협력)</a:t>
+            </a:r>
+          </a:p>
+          <a:p>
+            <a:pPr algn="l">
+              <a:spcBef>
+                <a:spcPts val="400"/>
+              </a:spcBef>
+              <a:spcAft>
+                <a:spcPts val="100"/>
+              </a:spcAft>
+            </a:pPr>
+            <a:r>
+              <a:rPr sz="1000" b="0">
+                <a:solidFill>
+                  <a:srgbClr val="EEEEEE"/>
+                </a:solidFill>
+                <a:latin typeface="맑은 고딕"/>
+              </a:rPr>
+              <a:t>• IRA $7,500 세액공제 즉시 현장 적용</a:t>
             </a:r>
           </a:p>
         </p:txBody>
@@ -16670,14 +17043,14 @@
         </p:nvSpPr>
         <p:spPr>
           <a:xfrm>
-            <a:off x="5458000" y="1900000"/>
-            <a:ext cx="1596000" cy="4100000"/>
+            <a:off x="450000" y="4040000"/>
+            <a:ext cx="4065000" cy="2100000"/>
           </a:xfrm>
           <a:prstGeom prst="rect">
             <a:avLst/>
           </a:prstGeom>
           <a:solidFill>
-            <a:srgbClr val="3D3D3D"/>
+            <a:srgbClr val="555555"/>
           </a:solidFill>
           <a:ln>
             <a:noFill/>
@@ -16701,12 +17074,12 @@
           <a:bodyPr rtlCol="0" anchor="ctr" wrap="square"/>
           <a:lstStyle/>
           <a:p>
-            <a:pPr algn="ctr">
+            <a:pPr algn="l">
               <a:spcBef>
-                <a:spcPts val="1200"/>
+                <a:spcPts val="1000"/>
               </a:spcBef>
               <a:spcAft>
-                <a:spcPts val="600"/>
+                <a:spcPts val="100"/>
               </a:spcAft>
             </a:pPr>
             <a:r>
@@ -16716,42 +17089,102 @@
                 </a:solidFill>
                 <a:latin typeface="맑은 고딕"/>
               </a:rPr>
-              <a:t>④ 세입자 충전</a:t>
-            </a:r>
-            <a:br/>
-            <a:r>
-              <a:t>솔루션</a:t>
+              <a:t>④  세입자 충전 솔루션</a:t>
             </a:r>
           </a:p>
           <a:p>
             <a:pPr algn="l">
               <a:spcBef>
-                <a:spcPts val="600"/>
+                <a:spcPts val="300"/>
               </a:spcBef>
               <a:spcAft>
-                <a:spcPts val="200"/>
+                <a:spcPts val="100"/>
               </a:spcAft>
             </a:pPr>
             <a:r>
-              <a:rPr sz="900" b="0">
+              <a:rPr sz="1000" b="0">
+                <a:solidFill>
+                  <a:srgbClr val="FFEEAA"/>
+                </a:solidFill>
+                <a:latin typeface="맑은 고딕"/>
+              </a:rPr>
+              <a:t>미국 인구 36% — 미개척 최대 시장</a:t>
+            </a:r>
+          </a:p>
+          <a:p>
+            <a:pPr algn="l">
+              <a:spcBef>
+                <a:spcPts val="400"/>
+              </a:spcBef>
+              <a:spcAft>
+                <a:spcPts val="100"/>
+              </a:spcAft>
+            </a:pPr>
+            <a:r>
+              <a:rPr sz="1000" b="0">
                 <a:solidFill>
                   <a:srgbClr val="EEEEEE"/>
                 </a:solidFill>
                 <a:latin typeface="맑은 고딕"/>
               </a:rPr>
-              <a:t>공동주택 충전 설치 지원</a:t>
-            </a:r>
-            <a:br/>
-            <a:r>
-              <a:t>부동산사 파트너십</a:t>
-            </a:r>
-            <a:br/>
-            <a:r>
-              <a:t>미국 인구 36% 세입자</a:t>
-            </a:r>
-            <a:br/>
-            <a:r>
-              <a:t>→ 미개척 최대 시장</a:t>
+              <a:t>• 공동주택 · 아파트 충전기 설치 지원 프로그램</a:t>
+            </a:r>
+          </a:p>
+          <a:p>
+            <a:pPr algn="l">
+              <a:spcBef>
+                <a:spcPts val="400"/>
+              </a:spcBef>
+              <a:spcAft>
+                <a:spcPts val="100"/>
+              </a:spcAft>
+            </a:pPr>
+            <a:r>
+              <a:rPr sz="1000" b="0">
+                <a:solidFill>
+                  <a:srgbClr val="EEEEEE"/>
+                </a:solidFill>
+                <a:latin typeface="맑은 고딕"/>
+              </a:rPr>
+              <a:t>• 부동산 개발사 · 아파트 운영사 파트너십</a:t>
+            </a:r>
+          </a:p>
+          <a:p>
+            <a:pPr algn="l">
+              <a:spcBef>
+                <a:spcPts val="400"/>
+              </a:spcBef>
+              <a:spcAft>
+                <a:spcPts val="100"/>
+              </a:spcAft>
+            </a:pPr>
+            <a:r>
+              <a:rPr sz="1000" b="0">
+                <a:solidFill>
+                  <a:srgbClr val="EEEEEE"/>
+                </a:solidFill>
+                <a:latin typeface="맑은 고딕"/>
+              </a:rPr>
+              <a:t>• 신축 건물 EV 충전 기본 설치 의무화 로비</a:t>
+            </a:r>
+          </a:p>
+          <a:p>
+            <a:pPr algn="l">
+              <a:spcBef>
+                <a:spcPts val="400"/>
+              </a:spcBef>
+              <a:spcAft>
+                <a:spcPts val="100"/>
+              </a:spcAft>
+            </a:pPr>
+            <a:r>
+              <a:rPr sz="1000" b="0">
+                <a:solidFill>
+                  <a:srgbClr val="EEEEEE"/>
+                </a:solidFill>
+                <a:latin typeface="맑은 고딕"/>
+              </a:rPr>
+              <a:t>• 흑인 55% · 라틴계 52% 세입자 → 형평성 직결</a:t>
             </a:r>
           </a:p>
         </p:txBody>
@@ -16764,14 +17197,14 @@
         </p:nvSpPr>
         <p:spPr>
           <a:xfrm>
-            <a:off x="7134000" y="1900000"/>
-            <a:ext cx="1596000" cy="4100000"/>
+            <a:off x="4585000" y="4040000"/>
+            <a:ext cx="4065000" cy="2100000"/>
           </a:xfrm>
           <a:prstGeom prst="rect">
             <a:avLst/>
           </a:prstGeom>
           <a:solidFill>
-            <a:srgbClr val="279E60"/>
+            <a:srgbClr val="1E8B4C"/>
           </a:solidFill>
           <a:ln>
             <a:noFill/>
@@ -16795,12 +17228,12 @@
           <a:bodyPr rtlCol="0" anchor="ctr" wrap="square"/>
           <a:lstStyle/>
           <a:p>
-            <a:pPr algn="ctr">
+            <a:pPr algn="l">
               <a:spcBef>
-                <a:spcPts val="1200"/>
+                <a:spcPts val="1000"/>
               </a:spcBef>
               <a:spcAft>
-                <a:spcPts val="600"/>
+                <a:spcPts val="100"/>
               </a:spcAft>
             </a:pPr>
             <a:r>
@@ -16810,42 +17243,102 @@
                 </a:solidFill>
                 <a:latin typeface="맑은 고딕"/>
               </a:rPr>
-              <a:t>⑤ 커뮤니티</a:t>
-            </a:r>
-            <a:br/>
-            <a:r>
-              <a:t>신뢰 구축</a:t>
+              <a:t>⑤  커뮤니티 신뢰 구축</a:t>
             </a:r>
           </a:p>
           <a:p>
             <a:pPr algn="l">
               <a:spcBef>
-                <a:spcPts val="600"/>
+                <a:spcPts val="300"/>
               </a:spcBef>
               <a:spcAft>
-                <a:spcPts val="200"/>
+                <a:spcPts val="100"/>
               </a:spcAft>
             </a:pPr>
             <a:r>
-              <a:rPr sz="900" b="0">
+              <a:rPr sz="1000" b="0">
+                <a:solidFill>
+                  <a:srgbClr val="FFEEAA"/>
+                </a:solidFill>
+                <a:latin typeface="맑은 고딕"/>
+              </a:rPr>
+              <a:t>기술 이전에 '신뢰'가 먼저</a:t>
+            </a:r>
+          </a:p>
+          <a:p>
+            <a:pPr algn="l">
+              <a:spcBef>
+                <a:spcPts val="400"/>
+              </a:spcBef>
+              <a:spcAft>
+                <a:spcPts val="100"/>
+              </a:spcAft>
+            </a:pPr>
+            <a:r>
+              <a:rPr sz="1000" b="0">
                 <a:solidFill>
                   <a:srgbClr val="EEEEEE"/>
                 </a:solidFill>
                 <a:latin typeface="맑은 고딕"/>
               </a:rPr>
-              <a:t>교육·시승 프로그램</a:t>
-            </a:r>
-            <a:br/>
-            <a:r>
-              <a:t>다양성 반영 마케팅</a:t>
-            </a:r>
-            <a:br/>
-            <a:r>
-              <a:t>BlueHub Capital 협력</a:t>
-            </a:r>
-            <a:br/>
-            <a:r>
-              <a:t>현지 서비스센터 확대</a:t>
+              <a:t>• 저소득 커뮤니티 EV 교육 · 시승 프로그램</a:t>
+            </a:r>
+          </a:p>
+          <a:p>
+            <a:pPr algn="l">
+              <a:spcBef>
+                <a:spcPts val="400"/>
+              </a:spcBef>
+              <a:spcAft>
+                <a:spcPts val="100"/>
+              </a:spcAft>
+            </a:pPr>
+            <a:r>
+              <a:rPr sz="1000" b="0">
+                <a:solidFill>
+                  <a:srgbClr val="EEEEEE"/>
+                </a:solidFill>
+                <a:latin typeface="맑은 고딕"/>
+              </a:rPr>
+              <a:t>• BlueHub Capital 등 비영리단체 협력</a:t>
+            </a:r>
+          </a:p>
+          <a:p>
+            <a:pPr algn="l">
+              <a:spcBef>
+                <a:spcPts val="400"/>
+              </a:spcBef>
+              <a:spcAft>
+                <a:spcPts val="100"/>
+              </a:spcAft>
+            </a:pPr>
+            <a:r>
+              <a:rPr sz="1000" b="0">
+                <a:solidFill>
+                  <a:srgbClr val="EEEEEE"/>
+                </a:solidFill>
+                <a:latin typeface="맑은 고딕"/>
+              </a:rPr>
+              <a:t>• 다양성 반영 마케팅 콘텐츠 제작</a:t>
+            </a:r>
+          </a:p>
+          <a:p>
+            <a:pPr algn="l">
+              <a:spcBef>
+                <a:spcPts val="400"/>
+              </a:spcBef>
+              <a:spcAft>
+                <a:spcPts val="100"/>
+              </a:spcAft>
+            </a:pPr>
+            <a:r>
+              <a:rPr sz="1000" b="0">
+                <a:solidFill>
+                  <a:srgbClr val="EEEEEE"/>
+                </a:solidFill>
+                <a:latin typeface="맑은 고딕"/>
+              </a:rPr>
+              <a:t>• 도심 저소득 지역 서비스센터 확대</a:t>
             </a:r>
           </a:p>
         </p:txBody>
@@ -16858,14 +17351,14 @@
         </p:nvSpPr>
         <p:spPr>
           <a:xfrm>
-            <a:off x="430000" y="6100000"/>
-            <a:ext cx="8220000" cy="260000"/>
+            <a:off x="450000" y="6210000"/>
+            <a:ext cx="8200000" cy="300000"/>
           </a:xfrm>
           <a:prstGeom prst="rect">
             <a:avLst/>
           </a:prstGeom>
           <a:solidFill>
-            <a:srgbClr val="F4F4F4"/>
+            <a:srgbClr val="1A1A1A"/>
           </a:solidFill>
           <a:ln>
             <a:noFill/>
@@ -16891,20 +17384,20 @@
           <a:p>
             <a:pPr algn="ctr">
               <a:spcBef>
-                <a:spcPts val="600"/>
+                <a:spcPts val="800"/>
               </a:spcBef>
               <a:spcAft>
-                <a:spcPts val="0"/>
+                <a:spcPts val="100"/>
               </a:spcAft>
             </a:pPr>
             <a:r>
               <a:rPr sz="1000" b="1">
                 <a:solidFill>
-                  <a:srgbClr val="3D3D3D"/>
+                  <a:srgbClr val="FFCC00"/>
                 </a:solidFill>
                 <a:latin typeface="맑은 고딕"/>
               </a:rPr>
-              <a:t>우선순위  ①저비용제조 ≥ ②충전인프라  &gt;  ③금융접근성 ≥ ④세입자  &gt;  ⑤커뮤니티  —  생태계 전체를 함께 구축</a:t>
+              <a:t>우선순위  ①저비용제조  ≥  ②충전인프라  &gt;  ③금융접근성  ≥  ④세입자솔루션  &gt;  ⑤커뮤니티신뢰  —  생태계 전체를 함께 구축</a:t>
             </a:r>
           </a:p>
         </p:txBody>

</xml_diff>